<commit_message>
One tool, one page: the salary tools live in the hub
Take-home pay, the 50/25/25 split, the payday router, the tax shield and
salary negotiation were each a page and a tab of the Salary & Pay Hub,
running the same calculation twice. The five pages and the four calculator
components only they used are removed; the old addresses redirect
permanently to the matching hub tab (/tools/salary#takehome, #allocate,
#route, #shield, #negotiate). The hub reads its tab from the address, so
each tab is linkable and the back button works. Links, registry, sitemap,
glossary, FAQs, manifest and the partnership deck (26 -> 21 calculators)
follow. The hub's overspent message states the shortfall again. Tests that
encoded the old structure are rewritten, not deleted: the five old-address
flows now assert the redirect lands on the right tab.

Co-Authored-By: Claude Sonnet 5.5 <noreply@anthropic.com>
Claude-Session: https://claude.ai/code/session_01SW7AAhG6987WGY5UWymi4C
</commit_message>
<xml_diff>
--- a/web/public/partners/jipange-mwangaza-partnership-deck.pptx
+++ b/web/public/partners/jipange-mwangaza-partnership-deck.pptx
@@ -1019,7 +1019,7 @@
                 <a:latin typeface="QuattrocentoSans"/>
                 <a:ea typeface="QuattrocentoSans"/>
               </a:rPr>
-              <a:t>Kenya's financial planning copilot — 26 calculators, 6 goal planners, a 90-second Pesa Picture.</a:t>
+              <a:t>Kenya's financial planning copilot — 21 calculators, 6 goal planners, a 90-second Pesa Picture.</a:t>
             </a:r>
             <a:endParaRPr lang="en-US" sz="1600" noProof="1"/>
           </a:p>
@@ -1499,7 +1499,7 @@
                 <a:latin typeface="QuattrocentoSans"/>
                 <a:ea typeface="QuattrocentoSans"/>
               </a:rPr>
-              <a:t>Where does my money go? Which vehicle fits my life stage and goal? JiPange answers with 26 calculators and 6 goal planners built on Kenya's actual financial architecture. Its investment-returns and retirement tools surface government bonds — and hand the user directly to Mwangaza to act.</a:t>
+              <a:t>Where does my money go? Which vehicle fits my life stage and goal? JiPange answers with 21 calculators and 6 goal planners built on Kenya's actual financial architecture. Its investment-returns and retirement tools surface government bonds — and hand the user directly to Mwangaza to act.</a:t>
             </a:r>
             <a:endParaRPr lang="en-US" sz="1100" noProof="1"/>
           </a:p>
@@ -6875,7 +6875,7 @@
                 <a:latin typeface="MiSans"/>
                 <a:ea typeface="MiSans"/>
               </a:rPr>
-              <a:t>JiPange: 26 calculators, 6 planners. Mwangaza: 58 bonds, 387 auction records. Both live; mobile money exceeds $300B a year — 5% of GDP.</a:t>
+              <a:t>JiPange: 21 calculators, 6 planners. Mwangaza: 58 bonds, 387 auction records. Both live; mobile money exceeds $300B a year — 5% of GDP.</a:t>
             </a:r>
             <a:endParaRPr lang="en-US" sz="1600" noProof="1"/>
           </a:p>
@@ -8626,7 +8626,7 @@
                 <a:latin typeface="QuattrocentoSans"/>
                 <a:ea typeface="QuattrocentoSans"/>
               </a:rPr>
-              <a:t>Live now — 26 calculators, 6 planners, a 90-second Pesa Picture. Free to explore today.</a:t>
+              <a:t>Live now — 21 calculators, 6 planners, a 90-second Pesa Picture. Free to explore today.</a:t>
             </a:r>
             <a:endParaRPr lang="en-US" sz="1600" noProof="1"/>
           </a:p>
@@ -13294,7 +13294,7 @@
                 <a:latin typeface="Oranienbaum"/>
                 <a:ea typeface="Oranienbaum"/>
               </a:rPr>
-              <a:t>26 calculators</a:t>
+              <a:t>21 calculators</a:t>
             </a:r>
             <a:endParaRPr lang="en-US" sz="1600" noProof="1"/>
           </a:p>
@@ -13598,7 +13598,7 @@
                 <a:latin typeface="Oranienbaum"/>
                 <a:ea typeface="Oranienbaum"/>
               </a:rPr>
-              <a:t>26 calculators that speak Kenya's financial language</a:t>
+              <a:t>21 calculators that speak Kenya's financial language</a:t>
             </a:r>
             <a:endParaRPr lang="en-US" sz="3100" noProof="1"/>
           </a:p>

</xml_diff>

<commit_message>
One tool, one page: the salary tools live in the hub (#243)
Take-home pay, the 50/25/25 split, the payday router, the tax shield and
salary negotiation were each a page and a tab of the Salary & Pay Hub,
running the same calculation twice. The five pages and the four calculator
components only they used are removed; the old addresses redirect
permanently to the matching hub tab (/tools/salary#takehome, #allocate,
#route, #shield, #negotiate). The hub reads its tab from the address, so
each tab is linkable and the back button works. Links, registry, sitemap,
glossary, FAQs, manifest and the partnership deck (26 -> 21 calculators)
follow. The hub's overspent message states the shortfall again. Tests that
encoded the old structure are rewritten, not deleted: the five old-address
flows now assert the redirect lands on the right tab.


Claude-Session: https://claude.ai/code/session_01SW7AAhG6987WGY5UWymi4C

Co-authored-by: Claude <noreply@anthropic.com>
</commit_message>
<xml_diff>
--- a/web/public/partners/jipange-mwangaza-partnership-deck.pptx
+++ b/web/public/partners/jipange-mwangaza-partnership-deck.pptx
@@ -1019,7 +1019,7 @@
                 <a:latin typeface="QuattrocentoSans"/>
                 <a:ea typeface="QuattrocentoSans"/>
               </a:rPr>
-              <a:t>Kenya's financial planning copilot — 26 calculators, 6 goal planners, a 90-second Pesa Picture.</a:t>
+              <a:t>Kenya's financial planning copilot — 21 calculators, 6 goal planners, a 90-second Pesa Picture.</a:t>
             </a:r>
             <a:endParaRPr lang="en-US" sz="1600" noProof="1"/>
           </a:p>
@@ -1499,7 +1499,7 @@
                 <a:latin typeface="QuattrocentoSans"/>
                 <a:ea typeface="QuattrocentoSans"/>
               </a:rPr>
-              <a:t>Where does my money go? Which vehicle fits my life stage and goal? JiPange answers with 26 calculators and 6 goal planners built on Kenya's actual financial architecture. Its investment-returns and retirement tools surface government bonds — and hand the user directly to Mwangaza to act.</a:t>
+              <a:t>Where does my money go? Which vehicle fits my life stage and goal? JiPange answers with 21 calculators and 6 goal planners built on Kenya's actual financial architecture. Its investment-returns and retirement tools surface government bonds — and hand the user directly to Mwangaza to act.</a:t>
             </a:r>
             <a:endParaRPr lang="en-US" sz="1100" noProof="1"/>
           </a:p>
@@ -6875,7 +6875,7 @@
                 <a:latin typeface="MiSans"/>
                 <a:ea typeface="MiSans"/>
               </a:rPr>
-              <a:t>JiPange: 26 calculators, 6 planners. Mwangaza: 58 bonds, 387 auction records. Both live; mobile money exceeds $300B a year — 5% of GDP.</a:t>
+              <a:t>JiPange: 21 calculators, 6 planners. Mwangaza: 58 bonds, 387 auction records. Both live; mobile money exceeds $300B a year — 5% of GDP.</a:t>
             </a:r>
             <a:endParaRPr lang="en-US" sz="1600" noProof="1"/>
           </a:p>
@@ -8626,7 +8626,7 @@
                 <a:latin typeface="QuattrocentoSans"/>
                 <a:ea typeface="QuattrocentoSans"/>
               </a:rPr>
-              <a:t>Live now — 26 calculators, 6 planners, a 90-second Pesa Picture. Free to explore today.</a:t>
+              <a:t>Live now — 21 calculators, 6 planners, a 90-second Pesa Picture. Free to explore today.</a:t>
             </a:r>
             <a:endParaRPr lang="en-US" sz="1600" noProof="1"/>
           </a:p>
@@ -13294,7 +13294,7 @@
                 <a:latin typeface="Oranienbaum"/>
                 <a:ea typeface="Oranienbaum"/>
               </a:rPr>
-              <a:t>26 calculators</a:t>
+              <a:t>21 calculators</a:t>
             </a:r>
             <a:endParaRPr lang="en-US" sz="1600" noProof="1"/>
           </a:p>
@@ -13598,7 +13598,7 @@
                 <a:latin typeface="Oranienbaum"/>
                 <a:ea typeface="Oranienbaum"/>
               </a:rPr>
-              <a:t>26 calculators that speak Kenya's financial language</a:t>
+              <a:t>21 calculators that speak Kenya's financial language</a:t>
             </a:r>
             <a:endParaRPr lang="en-US" sz="3100" noProof="1"/>
           </a:p>

</xml_diff>